<commit_message>
Fix overlapping bullet text on slide 2
Co-Authored-By: Claude Sonnet 4.6 <noreply@anthropic.com>
</commit_message>
<xml_diff>
--- a/HR_Churn_Presentation.pptx
+++ b/HR_Churn_Presentation.pptx
@@ -3692,7 +3692,7 @@
         </p:nvSpPr>
         <p:spPr>
           <a:xfrm>
-            <a:off x="457200" y="2057399"/>
+            <a:off x="457200" y="2103119"/>
             <a:ext cx="5349240" cy="292608"/>
           </a:xfrm>
           <a:prstGeom prst="rect">
@@ -3727,7 +3727,7 @@
         </p:nvSpPr>
         <p:spPr>
           <a:xfrm>
-            <a:off x="457200" y="2331719"/>
+            <a:off x="457200" y="2423159"/>
             <a:ext cx="5349240" cy="292608"/>
           </a:xfrm>
           <a:prstGeom prst="rect">
@@ -3762,7 +3762,7 @@
         </p:nvSpPr>
         <p:spPr>
           <a:xfrm>
-            <a:off x="457200" y="2606039"/>
+            <a:off x="457200" y="2743199"/>
             <a:ext cx="5349240" cy="292608"/>
           </a:xfrm>
           <a:prstGeom prst="rect">
@@ -3910,7 +3910,7 @@
         </p:nvSpPr>
         <p:spPr>
           <a:xfrm>
-            <a:off x="457200" y="4389120"/>
+            <a:off x="457200" y="4434840"/>
             <a:ext cx="5349240" cy="292608"/>
           </a:xfrm>
           <a:prstGeom prst="rect">
@@ -3945,7 +3945,7 @@
         </p:nvSpPr>
         <p:spPr>
           <a:xfrm>
-            <a:off x="457200" y="4663440"/>
+            <a:off x="457200" y="4754880"/>
             <a:ext cx="5349240" cy="292608"/>
           </a:xfrm>
           <a:prstGeom prst="rect">
@@ -3980,7 +3980,7 @@
         </p:nvSpPr>
         <p:spPr>
           <a:xfrm>
-            <a:off x="457200" y="4937759"/>
+            <a:off x="457200" y="5074920"/>
             <a:ext cx="5349240" cy="292608"/>
           </a:xfrm>
           <a:prstGeom prst="rect">

</xml_diff>

<commit_message>
Expand presentation to ~10 min with insight box and conclusion slide
Co-Authored-By: Claude Sonnet 4.6 <noreply@anthropic.com>
</commit_message>
<xml_diff>
--- a/HR_Churn_Presentation.pptx
+++ b/HR_Churn_Presentation.pptx
@@ -11,6 +11,7 @@
     <p:sldId id="259" r:id="rId10"/>
     <p:sldId id="260" r:id="rId11"/>
     <p:sldId id="261" r:id="rId12"/>
+    <p:sldId id="262" r:id="rId13"/>
   </p:sldIdLst>
   <p:sldSz cx="12188952" cy="6858000" type="screen4x3"/>
   <p:notesSz cx="6858000" cy="9144000"/>
@@ -6927,6 +6928,183 @@
           </a:p>
         </p:txBody>
       </p:sp>
+      <p:sp>
+        <p:nvSpPr>
+          <p:cNvPr id="21" name="Rectangle 20"/>
+          <p:cNvSpPr/>
+          <p:nvPr/>
+        </p:nvSpPr>
+        <p:spPr>
+          <a:xfrm>
+            <a:off x="7800000" y="4750000"/>
+            <a:ext cx="4000000" cy="1650000"/>
+          </a:xfrm>
+          <a:prstGeom prst="rect">
+            <a:avLst/>
+          </a:prstGeom>
+          <a:solidFill>
+            <a:srgbClr val="E8F0F8"/>
+          </a:solidFill>
+          <a:ln w="19050">
+            <a:solidFill>
+              <a:srgbClr val="1F3A5F"/>
+            </a:solidFill>
+          </a:ln>
+        </p:spPr>
+        <p:style>
+          <a:lnRef idx="1">
+            <a:schemeClr val="accent1"/>
+          </a:lnRef>
+          <a:fillRef idx="3">
+            <a:schemeClr val="accent1"/>
+          </a:fillRef>
+          <a:effectRef idx="2">
+            <a:schemeClr val="accent1"/>
+          </a:effectRef>
+          <a:fontRef idx="minor">
+            <a:schemeClr val="lt1"/>
+          </a:fontRef>
+        </p:style>
+        <p:txBody>
+          <a:bodyPr rtlCol="0" anchor="ctr"/>
+          <a:lstStyle/>
+          <a:p>
+            <a:pPr algn="ctr"/>
+          </a:p>
+        </p:txBody>
+      </p:sp>
+      <p:sp>
+        <p:nvSpPr>
+          <p:cNvPr id="22" name="TextBox 21"/>
+          <p:cNvSpPr txBox="1"/>
+          <p:nvPr/>
+        </p:nvSpPr>
+        <p:spPr>
+          <a:xfrm>
+            <a:off x="7891440" y="4841440"/>
+            <a:ext cx="3817120" cy="320040"/>
+          </a:xfrm>
+          <a:prstGeom prst="rect">
+            <a:avLst/>
+          </a:prstGeom>
+          <a:noFill/>
+        </p:spPr>
+        <p:txBody>
+          <a:bodyPr wrap="square">
+            <a:spAutoFit/>
+          </a:bodyPr>
+          <a:lstStyle/>
+          <a:p>
+            <a:r>
+              <a:rPr sz="1300" b="1">
+                <a:solidFill>
+                  <a:srgbClr val="1F3A5F"/>
+                </a:solidFill>
+              </a:rPr>
+              <a:t>Key Salary Insights</a:t>
+            </a:r>
+          </a:p>
+        </p:txBody>
+      </p:sp>
+      <p:sp>
+        <p:nvSpPr>
+          <p:cNvPr id="23" name="TextBox 22"/>
+          <p:cNvSpPr txBox="1"/>
+          <p:nvPr/>
+        </p:nvSpPr>
+        <p:spPr>
+          <a:xfrm>
+            <a:off x="7891440" y="5207200"/>
+            <a:ext cx="3817120" cy="320040"/>
+          </a:xfrm>
+          <a:prstGeom prst="rect">
+            <a:avLst/>
+          </a:prstGeom>
+          <a:noFill/>
+        </p:spPr>
+        <p:txBody>
+          <a:bodyPr wrap="square">
+            <a:spAutoFit/>
+          </a:bodyPr>
+          <a:lstStyle/>
+          <a:p>
+            <a:r>
+              <a:rPr sz="1050" b="0">
+                <a:solidFill>
+                  <a:srgbClr val="222222"/>
+                </a:solidFill>
+              </a:rPr>
+              <a:t>• Low-salary employees approach ~30% turnover — nearly 1 in 3</a:t>
+            </a:r>
+          </a:p>
+        </p:txBody>
+      </p:sp>
+      <p:sp>
+        <p:nvSpPr>
+          <p:cNvPr id="24" name="TextBox 23"/>
+          <p:cNvSpPr txBox="1"/>
+          <p:nvPr/>
+        </p:nvSpPr>
+        <p:spPr>
+          <a:xfrm>
+            <a:off x="7891440" y="5572960"/>
+            <a:ext cx="3817120" cy="320040"/>
+          </a:xfrm>
+          <a:prstGeom prst="rect">
+            <a:avLst/>
+          </a:prstGeom>
+          <a:noFill/>
+        </p:spPr>
+        <p:txBody>
+          <a:bodyPr wrap="square">
+            <a:spAutoFit/>
+          </a:bodyPr>
+          <a:lstStyle/>
+          <a:p>
+            <a:r>
+              <a:rPr sz="1050" b="0">
+                <a:solidFill>
+                  <a:srgbClr val="222222"/>
+                </a:solidFill>
+              </a:rPr>
+              <a:t>• High-earners leave at only 6.6% — compensation clearly drives retention</a:t>
+            </a:r>
+          </a:p>
+        </p:txBody>
+      </p:sp>
+      <p:sp>
+        <p:nvSpPr>
+          <p:cNvPr id="25" name="TextBox 24"/>
+          <p:cNvSpPr txBox="1"/>
+          <p:nvPr/>
+        </p:nvSpPr>
+        <p:spPr>
+          <a:xfrm>
+            <a:off x="7891440" y="5938720"/>
+            <a:ext cx="3817120" cy="320040"/>
+          </a:xfrm>
+          <a:prstGeom prst="rect">
+            <a:avLst/>
+          </a:prstGeom>
+          <a:noFill/>
+        </p:spPr>
+        <p:txBody>
+          <a:bodyPr wrap="square">
+            <a:spAutoFit/>
+          </a:bodyPr>
+          <a:lstStyle/>
+          <a:p>
+            <a:r>
+              <a:rPr sz="1050" b="0">
+                <a:solidFill>
+                  <a:srgbClr val="222222"/>
+                </a:solidFill>
+              </a:rPr>
+              <a:t>• Salary adjustment offers the highest ROI for HR intervention</a:t>
+            </a:r>
+          </a:p>
+        </p:txBody>
+      </p:sp>
     </p:spTree>
   </p:cSld>
   <p:clrMapOvr>
@@ -7158,7 +7336,7 @@
         <p:spPr>
           <a:xfrm>
             <a:off x="1243584" y="5138928"/>
-            <a:ext cx="4928616" cy="1298448"/>
+            <a:ext cx="4928616" cy="1389888"/>
           </a:xfrm>
           <a:prstGeom prst="rect">
             <a:avLst/>
@@ -7270,7 +7448,7 @@
         </p:nvSpPr>
         <p:spPr>
           <a:xfrm>
-            <a:off x="1426464" y="5870448"/>
+            <a:off x="1426464" y="5916168"/>
             <a:ext cx="4608576" cy="292608"/>
           </a:xfrm>
           <a:prstGeom prst="rect">
@@ -7305,7 +7483,7 @@
         </p:nvSpPr>
         <p:spPr>
           <a:xfrm>
-            <a:off x="1426464" y="6144768"/>
+            <a:off x="1426464" y="6236208"/>
             <a:ext cx="4608576" cy="292608"/>
           </a:xfrm>
           <a:prstGeom prst="rect">
@@ -7341,7 +7519,7 @@
         <p:spPr>
           <a:xfrm>
             <a:off x="6629400" y="5138928"/>
-            <a:ext cx="4937760" cy="1298448"/>
+            <a:ext cx="4937760" cy="1389888"/>
           </a:xfrm>
           <a:prstGeom prst="rect">
             <a:avLst/>
@@ -7453,7 +7631,7 @@
         </p:nvSpPr>
         <p:spPr>
           <a:xfrm>
-            <a:off x="6812280" y="5870448"/>
+            <a:off x="6812280" y="5916168"/>
             <a:ext cx="4617720" cy="292608"/>
           </a:xfrm>
           <a:prstGeom prst="rect">
@@ -7488,7 +7666,7 @@
         </p:nvSpPr>
         <p:spPr>
           <a:xfrm>
-            <a:off x="6812280" y="6144768"/>
+            <a:off x="6812280" y="6236208"/>
             <a:ext cx="4617720" cy="292608"/>
           </a:xfrm>
           <a:prstGeom prst="rect">
@@ -9568,6 +9746,1009 @@
                 <a:latin typeface="Calibri"/>
               </a:rPr>
               <a:t>Brenda Murillo &amp; Lucinda Piña  |  CSUB  |  HR Employee Churn Analysis</a:t>
+            </a:r>
+          </a:p>
+        </p:txBody>
+      </p:sp>
+    </p:spTree>
+  </p:cSld>
+  <p:clrMapOvr>
+    <a:masterClrMapping/>
+  </p:clrMapOvr>
+</p:sld>
+</file>
+
+<file path=ppt/slides/slide7.xml><?xml version="1.0" encoding="utf-8"?>
+<p:sld xmlns:a="http://schemas.openxmlformats.org/drawingml/2006/main" xmlns:p="http://schemas.openxmlformats.org/presentationml/2006/main" xmlns:r="http://schemas.openxmlformats.org/officeDocument/2006/relationships">
+  <p:cSld>
+    <p:spTree>
+      <p:nvGrpSpPr>
+        <p:cNvPr id="1" name=""/>
+        <p:cNvGrpSpPr/>
+        <p:nvPr/>
+      </p:nvGrpSpPr>
+      <p:grpSpPr/>
+      <p:sp>
+        <p:nvSpPr>
+          <p:cNvPr id="2" name="Vertical Title 1"/>
+          <p:cNvSpPr>
+            <a:spLocks noGrp="1"/>
+          </p:cNvSpPr>
+          <p:nvPr>
+            <p:ph type="title" orient="vert"/>
+          </p:nvPr>
+        </p:nvSpPr>
+        <p:spPr/>
+        <p:txBody>
+          <a:bodyPr/>
+          <a:lstStyle/>
+          <a:p/>
+        </p:txBody>
+      </p:sp>
+      <p:sp>
+        <p:nvSpPr>
+          <p:cNvPr id="3" name="Vertical Text Placeholder 2"/>
+          <p:cNvSpPr>
+            <a:spLocks noGrp="1"/>
+          </p:cNvSpPr>
+          <p:nvPr>
+            <p:ph type="body" idx="1" orient="vert"/>
+          </p:nvPr>
+        </p:nvSpPr>
+        <p:spPr/>
+        <p:txBody>
+          <a:bodyPr/>
+          <a:lstStyle/>
+          <a:p/>
+        </p:txBody>
+      </p:sp>
+      <p:sp>
+        <p:nvSpPr>
+          <p:cNvPr id="4" name="Rectangle 3"/>
+          <p:cNvSpPr/>
+          <p:nvPr/>
+        </p:nvSpPr>
+        <p:spPr>
+          <a:xfrm>
+            <a:off x="0" y="0"/>
+            <a:ext cx="12188952" cy="6858000"/>
+          </a:xfrm>
+          <a:prstGeom prst="rect">
+            <a:avLst/>
+          </a:prstGeom>
+          <a:solidFill>
+            <a:srgbClr val="FFFFFF"/>
+          </a:solidFill>
+          <a:ln>
+            <a:noFill/>
+          </a:ln>
+        </p:spPr>
+        <p:style>
+          <a:lnRef idx="1">
+            <a:schemeClr val="accent1"/>
+          </a:lnRef>
+          <a:fillRef idx="3">
+            <a:schemeClr val="accent1"/>
+          </a:fillRef>
+          <a:effectRef idx="2">
+            <a:schemeClr val="accent1"/>
+          </a:effectRef>
+          <a:fontRef idx="minor">
+            <a:schemeClr val="lt1"/>
+          </a:fontRef>
+        </p:style>
+        <p:txBody>
+          <a:bodyPr rtlCol="0" anchor="ctr"/>
+          <a:lstStyle/>
+          <a:p>
+            <a:pPr algn="ctr"/>
+          </a:p>
+        </p:txBody>
+      </p:sp>
+      <p:sp>
+        <p:nvSpPr>
+          <p:cNvPr id="5" name="Rectangle 4"/>
+          <p:cNvSpPr/>
+          <p:nvPr/>
+        </p:nvSpPr>
+        <p:spPr>
+          <a:xfrm>
+            <a:off x="0" y="0"/>
+            <a:ext cx="12188952" cy="1188720"/>
+          </a:xfrm>
+          <a:prstGeom prst="rect">
+            <a:avLst/>
+          </a:prstGeom>
+          <a:solidFill>
+            <a:srgbClr val="1F3A5F"/>
+          </a:solidFill>
+          <a:ln>
+            <a:noFill/>
+          </a:ln>
+        </p:spPr>
+        <p:style>
+          <a:lnRef idx="1">
+            <a:schemeClr val="accent1"/>
+          </a:lnRef>
+          <a:fillRef idx="3">
+            <a:schemeClr val="accent1"/>
+          </a:fillRef>
+          <a:effectRef idx="2">
+            <a:schemeClr val="accent1"/>
+          </a:effectRef>
+          <a:fontRef idx="minor">
+            <a:schemeClr val="lt1"/>
+          </a:fontRef>
+        </p:style>
+        <p:txBody>
+          <a:bodyPr rtlCol="0" anchor="ctr"/>
+          <a:lstStyle/>
+          <a:p>
+            <a:pPr algn="ctr"/>
+          </a:p>
+        </p:txBody>
+      </p:sp>
+      <p:sp>
+        <p:nvSpPr>
+          <p:cNvPr id="6" name="TextBox 5"/>
+          <p:cNvSpPr txBox="1"/>
+          <p:nvPr/>
+        </p:nvSpPr>
+        <p:spPr>
+          <a:xfrm>
+            <a:off x="320040" y="91440"/>
+            <a:ext cx="11430000" cy="640080"/>
+          </a:xfrm>
+          <a:prstGeom prst="rect">
+            <a:avLst/>
+          </a:prstGeom>
+          <a:noFill/>
+        </p:spPr>
+        <p:txBody>
+          <a:bodyPr wrap="square">
+            <a:spAutoFit/>
+          </a:bodyPr>
+          <a:lstStyle/>
+          <a:p>
+            <a:r>
+              <a:rPr sz="2800" b="1">
+                <a:solidFill>
+                  <a:srgbClr val="FFFFFF"/>
+                </a:solidFill>
+              </a:rPr>
+              <a:t>Conclusion &amp; Next Steps</a:t>
+            </a:r>
+          </a:p>
+        </p:txBody>
+      </p:sp>
+      <p:sp>
+        <p:nvSpPr>
+          <p:cNvPr id="7" name="TextBox 6"/>
+          <p:cNvSpPr txBox="1"/>
+          <p:nvPr/>
+        </p:nvSpPr>
+        <p:spPr>
+          <a:xfrm>
+            <a:off x="320040" y="713232"/>
+            <a:ext cx="10972800" cy="411480"/>
+          </a:xfrm>
+          <a:prstGeom prst="rect">
+            <a:avLst/>
+          </a:prstGeom>
+          <a:noFill/>
+        </p:spPr>
+        <p:txBody>
+          <a:bodyPr wrap="square">
+            <a:spAutoFit/>
+          </a:bodyPr>
+          <a:lstStyle/>
+          <a:p>
+            <a:r>
+              <a:rPr sz="1400" b="0">
+                <a:solidFill>
+                  <a:srgbClr val="CCDDFF"/>
+                </a:solidFill>
+              </a:rPr>
+              <a:t>Three findings. 615 at-risk employees. A clear path forward.</a:t>
+            </a:r>
+          </a:p>
+        </p:txBody>
+      </p:sp>
+      <p:sp>
+        <p:nvSpPr>
+          <p:cNvPr id="8" name="Rectangle 7"/>
+          <p:cNvSpPr/>
+          <p:nvPr/>
+        </p:nvSpPr>
+        <p:spPr>
+          <a:xfrm>
+            <a:off x="0" y="6537960"/>
+            <a:ext cx="12188952" cy="320040"/>
+          </a:xfrm>
+          <a:prstGeom prst="rect">
+            <a:avLst/>
+          </a:prstGeom>
+          <a:solidFill>
+            <a:srgbClr val="1F3A5F"/>
+          </a:solidFill>
+          <a:ln>
+            <a:noFill/>
+          </a:ln>
+        </p:spPr>
+        <p:style>
+          <a:lnRef idx="1">
+            <a:schemeClr val="accent1"/>
+          </a:lnRef>
+          <a:fillRef idx="3">
+            <a:schemeClr val="accent1"/>
+          </a:fillRef>
+          <a:effectRef idx="2">
+            <a:schemeClr val="accent1"/>
+          </a:effectRef>
+          <a:fontRef idx="minor">
+            <a:schemeClr val="lt1"/>
+          </a:fontRef>
+        </p:style>
+        <p:txBody>
+          <a:bodyPr rtlCol="0" anchor="ctr"/>
+          <a:lstStyle/>
+          <a:p>
+            <a:pPr algn="ctr"/>
+          </a:p>
+        </p:txBody>
+      </p:sp>
+      <p:sp>
+        <p:nvSpPr>
+          <p:cNvPr id="9" name="TextBox 8"/>
+          <p:cNvSpPr txBox="1"/>
+          <p:nvPr/>
+        </p:nvSpPr>
+        <p:spPr>
+          <a:xfrm>
+            <a:off x="274320" y="6556248"/>
+            <a:ext cx="10972800" cy="256032"/>
+          </a:xfrm>
+          <a:prstGeom prst="rect">
+            <a:avLst/>
+          </a:prstGeom>
+          <a:noFill/>
+        </p:spPr>
+        <p:txBody>
+          <a:bodyPr wrap="square">
+            <a:spAutoFit/>
+          </a:bodyPr>
+          <a:lstStyle/>
+          <a:p>
+            <a:r>
+              <a:rPr sz="1000" b="0">
+                <a:solidFill>
+                  <a:srgbClr val="AACCFF"/>
+                </a:solidFill>
+              </a:rPr>
+              <a:t>Brenda Murillo &amp; Lucinda Piña  |  CSUB  |  HR Employee Churn Analysis</a:t>
+            </a:r>
+          </a:p>
+        </p:txBody>
+      </p:sp>
+      <p:sp>
+        <p:nvSpPr>
+          <p:cNvPr id="10" name="Rectangle 9"/>
+          <p:cNvSpPr/>
+          <p:nvPr/>
+        </p:nvSpPr>
+        <p:spPr>
+          <a:xfrm>
+            <a:off x="274320" y="1325880"/>
+            <a:ext cx="3819144" cy="5120640"/>
+          </a:xfrm>
+          <a:prstGeom prst="rect">
+            <a:avLst/>
+          </a:prstGeom>
+          <a:solidFill>
+            <a:srgbClr val="1F3A5F"/>
+          </a:solidFill>
+          <a:ln>
+            <a:noFill/>
+          </a:ln>
+        </p:spPr>
+        <p:style>
+          <a:lnRef idx="1">
+            <a:schemeClr val="accent1"/>
+          </a:lnRef>
+          <a:fillRef idx="3">
+            <a:schemeClr val="accent1"/>
+          </a:fillRef>
+          <a:effectRef idx="2">
+            <a:schemeClr val="accent1"/>
+          </a:effectRef>
+          <a:fontRef idx="minor">
+            <a:schemeClr val="lt1"/>
+          </a:fontRef>
+        </p:style>
+        <p:txBody>
+          <a:bodyPr rtlCol="0" anchor="ctr"/>
+          <a:lstStyle/>
+          <a:p>
+            <a:pPr algn="ctr"/>
+          </a:p>
+        </p:txBody>
+      </p:sp>
+      <p:sp>
+        <p:nvSpPr>
+          <p:cNvPr id="11" name="TextBox 10"/>
+          <p:cNvSpPr txBox="1"/>
+          <p:nvPr/>
+        </p:nvSpPr>
+        <p:spPr>
+          <a:xfrm>
+            <a:off x="411480" y="1463040"/>
+            <a:ext cx="3544824" cy="365760"/>
+          </a:xfrm>
+          <a:prstGeom prst="rect">
+            <a:avLst/>
+          </a:prstGeom>
+          <a:noFill/>
+        </p:spPr>
+        <p:txBody>
+          <a:bodyPr wrap="square">
+            <a:spAutoFit/>
+          </a:bodyPr>
+          <a:lstStyle/>
+          <a:p>
+            <a:r>
+              <a:rPr sz="1600" b="1">
+                <a:solidFill>
+                  <a:srgbClr val="FFFFFF"/>
+                </a:solidFill>
+              </a:rPr>
+              <a:t>Key Findings</a:t>
+            </a:r>
+          </a:p>
+        </p:txBody>
+      </p:sp>
+      <p:sp>
+        <p:nvSpPr>
+          <p:cNvPr id="12" name="TextBox 11"/>
+          <p:cNvSpPr txBox="1"/>
+          <p:nvPr/>
+        </p:nvSpPr>
+        <p:spPr>
+          <a:xfrm>
+            <a:off x="411480" y="1965960"/>
+            <a:ext cx="3544824" cy="548640"/>
+          </a:xfrm>
+          <a:prstGeom prst="rect">
+            <a:avLst/>
+          </a:prstGeom>
+          <a:noFill/>
+        </p:spPr>
+        <p:txBody>
+          <a:bodyPr wrap="square">
+            <a:spAutoFit/>
+          </a:bodyPr>
+          <a:lstStyle/>
+          <a:p>
+            <a:r>
+              <a:rPr sz="1100" b="0">
+                <a:solidFill>
+                  <a:srgbClr val="CCDDFF"/>
+                </a:solidFill>
+              </a:rPr>
+              <a:t>• Satisfaction (r = −0.39) is the single strongest predictor of turnover</a:t>
+            </a:r>
+          </a:p>
+        </p:txBody>
+      </p:sp>
+      <p:sp>
+        <p:nvSpPr>
+          <p:cNvPr id="13" name="TextBox 12"/>
+          <p:cNvSpPr txBox="1"/>
+          <p:nvPr/>
+        </p:nvSpPr>
+        <p:spPr>
+          <a:xfrm>
+            <a:off x="411480" y="2651760"/>
+            <a:ext cx="3544824" cy="548640"/>
+          </a:xfrm>
+          <a:prstGeom prst="rect">
+            <a:avLst/>
+          </a:prstGeom>
+          <a:noFill/>
+        </p:spPr>
+        <p:txBody>
+          <a:bodyPr wrap="square">
+            <a:spAutoFit/>
+          </a:bodyPr>
+          <a:lstStyle/>
+          <a:p>
+            <a:r>
+              <a:rPr sz="1100" b="0">
+                <a:solidFill>
+                  <a:srgbClr val="CCDDFF"/>
+                </a:solidFill>
+              </a:rPr>
+              <a:t>• Low-salary employees leave at 4.5× the rate of high earners</a:t>
+            </a:r>
+          </a:p>
+        </p:txBody>
+      </p:sp>
+      <p:sp>
+        <p:nvSpPr>
+          <p:cNvPr id="14" name="TextBox 13"/>
+          <p:cNvSpPr txBox="1"/>
+          <p:nvPr/>
+        </p:nvSpPr>
+        <p:spPr>
+          <a:xfrm>
+            <a:off x="411480" y="3337560"/>
+            <a:ext cx="3544824" cy="548640"/>
+          </a:xfrm>
+          <a:prstGeom prst="rect">
+            <a:avLst/>
+          </a:prstGeom>
+          <a:noFill/>
+        </p:spPr>
+        <p:txBody>
+          <a:bodyPr wrap="square">
+            <a:spAutoFit/>
+          </a:bodyPr>
+          <a:lstStyle/>
+          <a:p>
+            <a:r>
+              <a:rPr sz="1100" b="0">
+                <a:solidFill>
+                  <a:srgbClr val="CCDDFF"/>
+                </a:solidFill>
+              </a:rPr>
+              <a:t>• 615 current employees match the highest-risk profile today</a:t>
+            </a:r>
+          </a:p>
+        </p:txBody>
+      </p:sp>
+      <p:sp>
+        <p:nvSpPr>
+          <p:cNvPr id="15" name="TextBox 14"/>
+          <p:cNvSpPr txBox="1"/>
+          <p:nvPr/>
+        </p:nvSpPr>
+        <p:spPr>
+          <a:xfrm>
+            <a:off x="411480" y="4023360"/>
+            <a:ext cx="3544824" cy="548640"/>
+          </a:xfrm>
+          <a:prstGeom prst="rect">
+            <a:avLst/>
+          </a:prstGeom>
+          <a:noFill/>
+        </p:spPr>
+        <p:txBody>
+          <a:bodyPr wrap="square">
+            <a:spAutoFit/>
+          </a:bodyPr>
+          <a:lstStyle/>
+          <a:p>
+            <a:r>
+              <a:rPr sz="1100" b="0">
+                <a:solidFill>
+                  <a:srgbClr val="CCDDFF"/>
+                </a:solidFill>
+              </a:rPr>
+              <a:t>• Overworked staff (220+ hrs/month) show the highest departure rates</a:t>
+            </a:r>
+          </a:p>
+        </p:txBody>
+      </p:sp>
+      <p:sp>
+        <p:nvSpPr>
+          <p:cNvPr id="16" name="TextBox 15"/>
+          <p:cNvSpPr txBox="1"/>
+          <p:nvPr/>
+        </p:nvSpPr>
+        <p:spPr>
+          <a:xfrm>
+            <a:off x="411480" y="4709160"/>
+            <a:ext cx="3544824" cy="548640"/>
+          </a:xfrm>
+          <a:prstGeom prst="rect">
+            <a:avLst/>
+          </a:prstGeom>
+          <a:noFill/>
+        </p:spPr>
+        <p:txBody>
+          <a:bodyPr wrap="square">
+            <a:spAutoFit/>
+          </a:bodyPr>
+          <a:lstStyle/>
+          <a:p>
+            <a:r>
+              <a:rPr sz="1100" b="0">
+                <a:solidFill>
+                  <a:srgbClr val="CCDDFF"/>
+                </a:solidFill>
+              </a:rPr>
+              <a:t>• HR signals exist — they just aren't being analyzed proactively</a:t>
+            </a:r>
+          </a:p>
+        </p:txBody>
+      </p:sp>
+      <p:sp>
+        <p:nvSpPr>
+          <p:cNvPr id="17" name="Rectangle 16"/>
+          <p:cNvSpPr/>
+          <p:nvPr/>
+        </p:nvSpPr>
+        <p:spPr>
+          <a:xfrm>
+            <a:off x="4184904" y="1325880"/>
+            <a:ext cx="3819144" cy="5120640"/>
+          </a:xfrm>
+          <a:prstGeom prst="rect">
+            <a:avLst/>
+          </a:prstGeom>
+          <a:solidFill>
+            <a:srgbClr val="C0392B"/>
+          </a:solidFill>
+          <a:ln>
+            <a:noFill/>
+          </a:ln>
+        </p:spPr>
+        <p:style>
+          <a:lnRef idx="1">
+            <a:schemeClr val="accent1"/>
+          </a:lnRef>
+          <a:fillRef idx="3">
+            <a:schemeClr val="accent1"/>
+          </a:fillRef>
+          <a:effectRef idx="2">
+            <a:schemeClr val="accent1"/>
+          </a:effectRef>
+          <a:fontRef idx="minor">
+            <a:schemeClr val="lt1"/>
+          </a:fontRef>
+        </p:style>
+        <p:txBody>
+          <a:bodyPr rtlCol="0" anchor="ctr"/>
+          <a:lstStyle/>
+          <a:p>
+            <a:pPr algn="ctr"/>
+          </a:p>
+        </p:txBody>
+      </p:sp>
+      <p:sp>
+        <p:nvSpPr>
+          <p:cNvPr id="18" name="TextBox 17"/>
+          <p:cNvSpPr txBox="1"/>
+          <p:nvPr/>
+        </p:nvSpPr>
+        <p:spPr>
+          <a:xfrm>
+            <a:off x="4322064" y="1463040"/>
+            <a:ext cx="3544824" cy="365760"/>
+          </a:xfrm>
+          <a:prstGeom prst="rect">
+            <a:avLst/>
+          </a:prstGeom>
+          <a:noFill/>
+        </p:spPr>
+        <p:txBody>
+          <a:bodyPr wrap="square">
+            <a:spAutoFit/>
+          </a:bodyPr>
+          <a:lstStyle/>
+          <a:p>
+            <a:r>
+              <a:rPr sz="1600" b="1">
+                <a:solidFill>
+                  <a:srgbClr val="FFFFFF"/>
+                </a:solidFill>
+              </a:rPr>
+              <a:t>Business Impact</a:t>
+            </a:r>
+          </a:p>
+        </p:txBody>
+      </p:sp>
+      <p:sp>
+        <p:nvSpPr>
+          <p:cNvPr id="19" name="TextBox 18"/>
+          <p:cNvSpPr txBox="1"/>
+          <p:nvPr/>
+        </p:nvSpPr>
+        <p:spPr>
+          <a:xfrm>
+            <a:off x="4322064" y="1965960"/>
+            <a:ext cx="3544824" cy="548640"/>
+          </a:xfrm>
+          <a:prstGeom prst="rect">
+            <a:avLst/>
+          </a:prstGeom>
+          <a:noFill/>
+        </p:spPr>
+        <p:txBody>
+          <a:bodyPr wrap="square">
+            <a:spAutoFit/>
+          </a:bodyPr>
+          <a:lstStyle/>
+          <a:p>
+            <a:r>
+              <a:rPr sz="1100" b="0">
+                <a:solidFill>
+                  <a:srgbClr val="FFCCCC"/>
+                </a:solidFill>
+              </a:rPr>
+              <a:t>• Turnover costs 50–200% of each departing employee's annual salary</a:t>
+            </a:r>
+          </a:p>
+        </p:txBody>
+      </p:sp>
+      <p:sp>
+        <p:nvSpPr>
+          <p:cNvPr id="20" name="TextBox 19"/>
+          <p:cNvSpPr txBox="1"/>
+          <p:nvPr/>
+        </p:nvSpPr>
+        <p:spPr>
+          <a:xfrm>
+            <a:off x="4322064" y="2651760"/>
+            <a:ext cx="3544824" cy="548640"/>
+          </a:xfrm>
+          <a:prstGeom prst="rect">
+            <a:avLst/>
+          </a:prstGeom>
+          <a:noFill/>
+        </p:spPr>
+        <p:txBody>
+          <a:bodyPr wrap="square">
+            <a:spAutoFit/>
+          </a:bodyPr>
+          <a:lstStyle/>
+          <a:p>
+            <a:r>
+              <a:rPr sz="1100" b="0">
+                <a:solidFill>
+                  <a:srgbClr val="FFCCCC"/>
+                </a:solidFill>
+              </a:rPr>
+              <a:t>• 3,571 departures represent tens of millions in replacement costs</a:t>
+            </a:r>
+          </a:p>
+        </p:txBody>
+      </p:sp>
+      <p:sp>
+        <p:nvSpPr>
+          <p:cNvPr id="21" name="TextBox 20"/>
+          <p:cNvSpPr txBox="1"/>
+          <p:nvPr/>
+        </p:nvSpPr>
+        <p:spPr>
+          <a:xfrm>
+            <a:off x="4322064" y="3337560"/>
+            <a:ext cx="3544824" cy="548640"/>
+          </a:xfrm>
+          <a:prstGeom prst="rect">
+            <a:avLst/>
+          </a:prstGeom>
+          <a:noFill/>
+        </p:spPr>
+        <p:txBody>
+          <a:bodyPr wrap="square">
+            <a:spAutoFit/>
+          </a:bodyPr>
+          <a:lstStyle/>
+          <a:p>
+            <a:r>
+              <a:rPr sz="1100" b="0">
+                <a:solidFill>
+                  <a:srgbClr val="FFCCCC"/>
+                </a:solidFill>
+              </a:rPr>
+              <a:t>• Early outreach on 615 flagged employees could prevent the next wave</a:t>
+            </a:r>
+          </a:p>
+        </p:txBody>
+      </p:sp>
+      <p:sp>
+        <p:nvSpPr>
+          <p:cNvPr id="22" name="TextBox 21"/>
+          <p:cNvSpPr txBox="1"/>
+          <p:nvPr/>
+        </p:nvSpPr>
+        <p:spPr>
+          <a:xfrm>
+            <a:off x="4322064" y="4023360"/>
+            <a:ext cx="3544824" cy="548640"/>
+          </a:xfrm>
+          <a:prstGeom prst="rect">
+            <a:avLst/>
+          </a:prstGeom>
+          <a:noFill/>
+        </p:spPr>
+        <p:txBody>
+          <a:bodyPr wrap="square">
+            <a:spAutoFit/>
+          </a:bodyPr>
+          <a:lstStyle/>
+          <a:p>
+            <a:r>
+              <a:rPr sz="1100" b="0">
+                <a:solidFill>
+                  <a:srgbClr val="FFCCCC"/>
+                </a:solidFill>
+              </a:rPr>
+              <a:t>• Proactive, data-driven HR pays for itself in avoided rehiring costs</a:t>
+            </a:r>
+          </a:p>
+        </p:txBody>
+      </p:sp>
+      <p:sp>
+        <p:nvSpPr>
+          <p:cNvPr id="23" name="TextBox 22"/>
+          <p:cNvSpPr txBox="1"/>
+          <p:nvPr/>
+        </p:nvSpPr>
+        <p:spPr>
+          <a:xfrm>
+            <a:off x="4322064" y="4709160"/>
+            <a:ext cx="3544824" cy="548640"/>
+          </a:xfrm>
+          <a:prstGeom prst="rect">
+            <a:avLst/>
+          </a:prstGeom>
+          <a:noFill/>
+        </p:spPr>
+        <p:txBody>
+          <a:bodyPr wrap="square">
+            <a:spAutoFit/>
+          </a:bodyPr>
+          <a:lstStyle/>
+          <a:p>
+            <a:r>
+              <a:rPr sz="1100" b="0">
+                <a:solidFill>
+                  <a:srgbClr val="FFCCCC"/>
+                </a:solidFill>
+              </a:rPr>
+              <a:t>• SQL-based risk queries can scale to any HR dataset in hours</a:t>
+            </a:r>
+          </a:p>
+        </p:txBody>
+      </p:sp>
+      <p:sp>
+        <p:nvSpPr>
+          <p:cNvPr id="24" name="Rectangle 23"/>
+          <p:cNvSpPr/>
+          <p:nvPr/>
+        </p:nvSpPr>
+        <p:spPr>
+          <a:xfrm>
+            <a:off x="8095488" y="1325880"/>
+            <a:ext cx="3819144" cy="5120640"/>
+          </a:xfrm>
+          <a:prstGeom prst="rect">
+            <a:avLst/>
+          </a:prstGeom>
+          <a:solidFill>
+            <a:srgbClr val="7D3C98"/>
+          </a:solidFill>
+          <a:ln>
+            <a:noFill/>
+          </a:ln>
+        </p:spPr>
+        <p:style>
+          <a:lnRef idx="1">
+            <a:schemeClr val="accent1"/>
+          </a:lnRef>
+          <a:fillRef idx="3">
+            <a:schemeClr val="accent1"/>
+          </a:fillRef>
+          <a:effectRef idx="2">
+            <a:schemeClr val="accent1"/>
+          </a:effectRef>
+          <a:fontRef idx="minor">
+            <a:schemeClr val="lt1"/>
+          </a:fontRef>
+        </p:style>
+        <p:txBody>
+          <a:bodyPr rtlCol="0" anchor="ctr"/>
+          <a:lstStyle/>
+          <a:p>
+            <a:pPr algn="ctr"/>
+          </a:p>
+        </p:txBody>
+      </p:sp>
+      <p:sp>
+        <p:nvSpPr>
+          <p:cNvPr id="25" name="TextBox 24"/>
+          <p:cNvSpPr txBox="1"/>
+          <p:nvPr/>
+        </p:nvSpPr>
+        <p:spPr>
+          <a:xfrm>
+            <a:off x="8232648" y="1463040"/>
+            <a:ext cx="3544824" cy="365760"/>
+          </a:xfrm>
+          <a:prstGeom prst="rect">
+            <a:avLst/>
+          </a:prstGeom>
+          <a:noFill/>
+        </p:spPr>
+        <p:txBody>
+          <a:bodyPr wrap="square">
+            <a:spAutoFit/>
+          </a:bodyPr>
+          <a:lstStyle/>
+          <a:p>
+            <a:r>
+              <a:rPr sz="1600" b="1">
+                <a:solidFill>
+                  <a:srgbClr val="FFFFFF"/>
+                </a:solidFill>
+              </a:rPr>
+              <a:t>Future Work</a:t>
+            </a:r>
+          </a:p>
+        </p:txBody>
+      </p:sp>
+      <p:sp>
+        <p:nvSpPr>
+          <p:cNvPr id="26" name="TextBox 25"/>
+          <p:cNvSpPr txBox="1"/>
+          <p:nvPr/>
+        </p:nvSpPr>
+        <p:spPr>
+          <a:xfrm>
+            <a:off x="8232648" y="1965960"/>
+            <a:ext cx="3544824" cy="548640"/>
+          </a:xfrm>
+          <a:prstGeom prst="rect">
+            <a:avLst/>
+          </a:prstGeom>
+          <a:noFill/>
+        </p:spPr>
+        <p:txBody>
+          <a:bodyPr wrap="square">
+            <a:spAutoFit/>
+          </a:bodyPr>
+          <a:lstStyle/>
+          <a:p>
+            <a:r>
+              <a:rPr sz="1100" b="0">
+                <a:solidFill>
+                  <a:srgbClr val="E8CCFF"/>
+                </a:solidFill>
+              </a:rPr>
+              <a:t>• Train a Random Forest / Logistic Regression classifier for automated risk scoring</a:t>
+            </a:r>
+          </a:p>
+        </p:txBody>
+      </p:sp>
+      <p:sp>
+        <p:nvSpPr>
+          <p:cNvPr id="27" name="TextBox 26"/>
+          <p:cNvSpPr txBox="1"/>
+          <p:nvPr/>
+        </p:nvSpPr>
+        <p:spPr>
+          <a:xfrm>
+            <a:off x="8232648" y="2651760"/>
+            <a:ext cx="3544824" cy="548640"/>
+          </a:xfrm>
+          <a:prstGeom prst="rect">
+            <a:avLst/>
+          </a:prstGeom>
+          <a:noFill/>
+        </p:spPr>
+        <p:txBody>
+          <a:bodyPr wrap="square">
+            <a:spAutoFit/>
+          </a:bodyPr>
+          <a:lstStyle/>
+          <a:p>
+            <a:r>
+              <a:rPr sz="1100" b="0">
+                <a:solidFill>
+                  <a:srgbClr val="E8CCFF"/>
+                </a:solidFill>
+              </a:rPr>
+              <a:t>• Build a real-time HR dashboard powered by the risk-profiling SQL query</a:t>
+            </a:r>
+          </a:p>
+        </p:txBody>
+      </p:sp>
+      <p:sp>
+        <p:nvSpPr>
+          <p:cNvPr id="28" name="TextBox 27"/>
+          <p:cNvSpPr txBox="1"/>
+          <p:nvPr/>
+        </p:nvSpPr>
+        <p:spPr>
+          <a:xfrm>
+            <a:off x="8232648" y="3337560"/>
+            <a:ext cx="3544824" cy="548640"/>
+          </a:xfrm>
+          <a:prstGeom prst="rect">
+            <a:avLst/>
+          </a:prstGeom>
+          <a:noFill/>
+        </p:spPr>
+        <p:txBody>
+          <a:bodyPr wrap="square">
+            <a:spAutoFit/>
+          </a:bodyPr>
+          <a:lstStyle/>
+          <a:p>
+            <a:r>
+              <a:rPr sz="1100" b="0">
+                <a:solidFill>
+                  <a:srgbClr val="E8CCFF"/>
+                </a:solidFill>
+              </a:rPr>
+              <a:t>• Expand analysis to department-level and manager-level breakdowns</a:t>
+            </a:r>
+          </a:p>
+        </p:txBody>
+      </p:sp>
+      <p:sp>
+        <p:nvSpPr>
+          <p:cNvPr id="29" name="TextBox 28"/>
+          <p:cNvSpPr txBox="1"/>
+          <p:nvPr/>
+        </p:nvSpPr>
+        <p:spPr>
+          <a:xfrm>
+            <a:off x="8232648" y="4023360"/>
+            <a:ext cx="3544824" cy="548640"/>
+          </a:xfrm>
+          <a:prstGeom prst="rect">
+            <a:avLst/>
+          </a:prstGeom>
+          <a:noFill/>
+        </p:spPr>
+        <p:txBody>
+          <a:bodyPr wrap="square">
+            <a:spAutoFit/>
+          </a:bodyPr>
+          <a:lstStyle/>
+          <a:p>
+            <a:r>
+              <a:rPr sz="1100" b="0">
+                <a:solidFill>
+                  <a:srgbClr val="E8CCFF"/>
+                </a:solidFill>
+              </a:rPr>
+              <a:t>• Automate monthly at-risk employee reports for HR leadership</a:t>
+            </a:r>
+          </a:p>
+        </p:txBody>
+      </p:sp>
+      <p:sp>
+        <p:nvSpPr>
+          <p:cNvPr id="30" name="TextBox 29"/>
+          <p:cNvSpPr txBox="1"/>
+          <p:nvPr/>
+        </p:nvSpPr>
+        <p:spPr>
+          <a:xfrm>
+            <a:off x="8232648" y="4709160"/>
+            <a:ext cx="3544824" cy="548640"/>
+          </a:xfrm>
+          <a:prstGeom prst="rect">
+            <a:avLst/>
+          </a:prstGeom>
+          <a:noFill/>
+        </p:spPr>
+        <p:txBody>
+          <a:bodyPr wrap="square">
+            <a:spAutoFit/>
+          </a:bodyPr>
+          <a:lstStyle/>
+          <a:p>
+            <a:r>
+              <a:rPr sz="1100" b="0">
+                <a:solidFill>
+                  <a:srgbClr val="E8CCFF"/>
+                </a:solidFill>
+              </a:rPr>
+              <a:t>• Validate findings on real-world (non-simulated) HR datasets</a:t>
             </a:r>
           </a:p>
         </p:txBody>

</xml_diff>

<commit_message>
Fix slide 4: move insight bar above chart instead of overlapping it
Co-Authored-By: Claude Sonnet 4.6 <noreply@anthropic.com>
</commit_message>
<xml_diff>
--- a/HR_Churn_Presentation.pptx
+++ b/HR_Churn_Presentation.pptx
@@ -6842,8 +6842,8 @@
         </p:blipFill>
         <p:spPr>
           <a:xfrm>
-            <a:off x="274320" y="2651760"/>
-            <a:ext cx="11612880" cy="3870960"/>
+            <a:off x="274320" y="3291840"/>
+            <a:ext cx="11612880" cy="3230880"/>
           </a:xfrm>
           <a:prstGeom prst="rect">
             <a:avLst/>
@@ -6936,8 +6936,8 @@
         </p:nvSpPr>
         <p:spPr>
           <a:xfrm>
-            <a:off x="7800000" y="4750000"/>
-            <a:ext cx="4000000" cy="1650000"/>
+            <a:off x="274320" y="2514600"/>
+            <a:ext cx="11614872" cy="548640"/>
           </a:xfrm>
           <a:prstGeom prst="rect">
             <a:avLst/>
@@ -6945,7 +6945,7 @@
           <a:solidFill>
             <a:srgbClr val="E8F0F8"/>
           </a:solidFill>
-          <a:ln w="19050">
+          <a:ln w="12700">
             <a:solidFill>
               <a:srgbClr val="1F3A5F"/>
             </a:solidFill>
@@ -6981,27 +6981,27 @@
         </p:nvSpPr>
         <p:spPr>
           <a:xfrm>
-            <a:off x="7891440" y="4841440"/>
-            <a:ext cx="3817120" cy="320040"/>
-          </a:xfrm>
-          <a:prstGeom prst="rect">
-            <a:avLst/>
-          </a:prstGeom>
-          <a:noFill/>
-        </p:spPr>
-        <p:txBody>
-          <a:bodyPr wrap="square">
-            <a:spAutoFit/>
-          </a:bodyPr>
-          <a:lstStyle/>
-          <a:p>
-            <a:r>
-              <a:rPr sz="1300" b="1">
+            <a:off x="365760" y="2651760"/>
+            <a:ext cx="1800000" cy="274320"/>
+          </a:xfrm>
+          <a:prstGeom prst="rect">
+            <a:avLst/>
+          </a:prstGeom>
+          <a:noFill/>
+        </p:spPr>
+        <p:txBody>
+          <a:bodyPr wrap="square">
+            <a:spAutoFit/>
+          </a:bodyPr>
+          <a:lstStyle/>
+          <a:p>
+            <a:r>
+              <a:rPr sz="1100" b="1">
                 <a:solidFill>
                   <a:srgbClr val="1F3A5F"/>
                 </a:solidFill>
               </a:rPr>
-              <a:t>Key Salary Insights</a:t>
+              <a:t>Key Insight:</a:t>
             </a:r>
           </a:p>
         </p:txBody>
@@ -7014,8 +7014,8 @@
         </p:nvSpPr>
         <p:spPr>
           <a:xfrm>
-            <a:off x="7891440" y="5207200"/>
-            <a:ext cx="3817120" cy="320040"/>
+            <a:off x="2257200" y="2651760"/>
+            <a:ext cx="3088744" cy="274320"/>
           </a:xfrm>
           <a:prstGeom prst="rect">
             <a:avLst/>
@@ -7034,7 +7034,7 @@
                   <a:srgbClr val="222222"/>
                 </a:solidFill>
               </a:rPr>
-              <a:t>• Low-salary employees approach ~30% turnover — nearly 1 in 3</a:t>
+              <a:t>• Low-salary turnover ~30% — nearly 1 in 3 employees</a:t>
             </a:r>
           </a:p>
         </p:txBody>
@@ -7047,8 +7047,8 @@
         </p:nvSpPr>
         <p:spPr>
           <a:xfrm>
-            <a:off x="7891440" y="5572960"/>
-            <a:ext cx="3817120" cy="320040"/>
+            <a:off x="5437384" y="2651760"/>
+            <a:ext cx="3088744" cy="274320"/>
           </a:xfrm>
           <a:prstGeom prst="rect">
             <a:avLst/>
@@ -7067,7 +7067,7 @@
                   <a:srgbClr val="222222"/>
                 </a:solidFill>
               </a:rPr>
-              <a:t>• High-earners leave at only 6.6% — compensation clearly drives retention</a:t>
+              <a:t>• High-salary turnover 6.6% — pay clearly drives retention</a:t>
             </a:r>
           </a:p>
         </p:txBody>
@@ -7080,8 +7080,8 @@
         </p:nvSpPr>
         <p:spPr>
           <a:xfrm>
-            <a:off x="7891440" y="5938720"/>
-            <a:ext cx="3817120" cy="320040"/>
+            <a:off x="8617568" y="2651760"/>
+            <a:ext cx="3088744" cy="274320"/>
           </a:xfrm>
           <a:prstGeom prst="rect">
             <a:avLst/>
@@ -7100,7 +7100,7 @@
                   <a:srgbClr val="222222"/>
                 </a:solidFill>
               </a:rPr>
-              <a:t>• Salary adjustment offers the highest ROI for HR intervention</a:t>
+              <a:t>• Salary adjustment offers the highest ROI for HR action</a:t>
             </a:r>
           </a:p>
         </p:txBody>

</xml_diff>

<commit_message>
Fix slide 4 chart stretch: restore 3:1 aspect ratio and center
Co-Authored-By: Claude Sonnet 4.6 <noreply@anthropic.com>
</commit_message>
<xml_diff>
--- a/HR_Churn_Presentation.pptx
+++ b/HR_Churn_Presentation.pptx
@@ -6842,8 +6842,8 @@
         </p:blipFill>
         <p:spPr>
           <a:xfrm>
-            <a:off x="274320" y="3291840"/>
-            <a:ext cx="11612880" cy="3230880"/>
+            <a:off x="1362456" y="3291840"/>
+            <a:ext cx="9464040" cy="3154680"/>
           </a:xfrm>
           <a:prstGeom prst="rect">
             <a:avLst/>

</xml_diff>